<commit_message>
System Design 101 (vi): count the last compensation event in the sd-08-002 choreography totals
Co-Authored-By: Claude Sonnet 5.5 <noreply@anthropic.com>
Claude-Session: https://claude.ai/code/session_01DkN7YTqFfdjb8A8J5ehSWS
</commit_message>
<xml_diff>
--- a/system-design-101/vi/lessons/sd-08-002/slides/sd-08-002.pptx
+++ b/system-design-101/vi/lessons/sd-08-002/slides/sd-08-002.pptx
@@ -7199,7 +7199,7 @@
               <a:t> ba:</a:t>
             </a:r>
             <a:r>
-              <a:rPr lang="en-US" sz="6900" dirty="0" spc="-1" kern="0">
+              <a:rPr lang="en-US" sz="6900" dirty="0" spc="-2" kern="0">
                 <a:solidFill>
                   <a:srgbClr val="14161C"/>
                 </a:solidFill>
@@ -7207,7 +7207,7 @@
                 <a:ea typeface="Bricolage Grotesque ExtraBold" pitchFamily="34" charset="-122"/>
                 <a:cs typeface="Bricolage Grotesque ExtraBold" pitchFamily="34" charset="-120"/>
               </a:rPr>
-              <a:t> 5</a:t>
+              <a:t> 6</a:t>
             </a:r>
             <a:r>
               <a:rPr lang="en-US" sz="6900" dirty="0" spc="2" kern="0">
@@ -7974,7 +7974,7 @@
                         <a:buNone/>
                       </a:pPr>
                       <a:r>
-                        <a:rPr lang="en-US" sz="2400" b="1" dirty="0" spc="-5" kern="0">
+                        <a:rPr lang="en-US" sz="2400" b="1" dirty="0" spc="3" kern="0">
                           <a:solidFill>
                             <a:srgbClr val="E8472B"/>
                           </a:solidFill>
@@ -7982,7 +7982,7 @@
                           <a:ea typeface="Be Vietnam Pro" pitchFamily="34" charset="-122"/>
                           <a:cs typeface="Be Vietnam Pro" pitchFamily="34" charset="-120"/>
                         </a:rPr>
-                        <a:t>3</a:t>
+                        <a:t>4</a:t>
                       </a:r>
                       <a:endParaRPr lang="en-US" sz="1200" dirty="0"/>
                     </a:p>
@@ -8180,7 +8180,7 @@
                         <a:buNone/>
                       </a:pPr>
                       <a:r>
-                        <a:rPr lang="en-US" sz="2400" dirty="0" spc="4" kern="0">
+                        <a:rPr lang="en-US" sz="2400" dirty="0" spc="-6" kern="0">
                           <a:solidFill>
                             <a:srgbClr val="E8472B"/>
                           </a:solidFill>
@@ -8188,7 +8188,7 @@
                           <a:ea typeface="Be Vietnam Pro ExtraBold" pitchFamily="34" charset="-122"/>
                           <a:cs typeface="Be Vietnam Pro ExtraBold" pitchFamily="34" charset="-120"/>
                         </a:rPr>
-                        <a:t>5</a:t>
+                        <a:t>6</a:t>
                       </a:r>
                       <a:endParaRPr lang="en-US" sz="1200" dirty="0"/>
                     </a:p>
@@ -8386,7 +8386,7 @@
                         <a:buNone/>
                       </a:pPr>
                       <a:r>
-                        <a:rPr lang="en-US" sz="2400" b="1" dirty="0" spc="-2" kern="0">
+                        <a:rPr lang="en-US" sz="2400" b="1" dirty="0" spc="3" kern="0">
                           <a:solidFill>
                             <a:srgbClr val="E8472B"/>
                           </a:solidFill>
@@ -8394,7 +8394,7 @@
                           <a:ea typeface="Be Vietnam Pro" pitchFamily="34" charset="-122"/>
                           <a:cs typeface="Be Vietnam Pro" pitchFamily="34" charset="-120"/>
                         </a:rPr>
-                        <a:t>7</a:t>
+                        <a:t>8</a:t>
                       </a:r>
                       <a:endParaRPr lang="en-US" sz="1200" dirty="0"/>
                     </a:p>

</xml_diff>